<commit_message>
Add real UBL logo; retune accent to the mark's own blue
Logo cropped to its artwork and upscaled so it stays crisp at presentation
size. Appears on the deck cover and in both app headers automatically.

Accent colour re-sampled pixel-for-pixel from the logo itself (#0070B8) rather
than from the website's stylesheet, so the deck matches the mark exactly.
</commit_message>
<xml_diff>
--- a/Rehnuma_UBL_Presentation.pptx
+++ b/Rehnuma_UBL_Presentation.pptx
@@ -3928,59 +3928,30 @@
           </a:p>
         </p:txBody>
       </p:sp>
-      <p:sp>
-        <p:nvSpPr>
-          <p:cNvPr id="21" name="Rectangle 20"/>
-          <p:cNvSpPr/>
-          <p:nvPr/>
-        </p:nvSpPr>
-        <p:spPr>
-          <a:xfrm>
-            <a:off x="822960" y="658368"/>
-            <a:ext cx="817839" cy="475488"/>
-          </a:xfrm>
-          <a:prstGeom prst="rect">
-            <a:avLst/>
-          </a:prstGeom>
-          <a:solidFill>
-            <a:srgbClr val="0083CA"/>
-          </a:solidFill>
-          <a:ln>
-            <a:noFill/>
-          </a:ln>
-          <a:effectLst/>
-        </p:spPr>
-        <p:style>
-          <a:lnRef idx="1">
-            <a:schemeClr val="accent1"/>
-          </a:lnRef>
-          <a:fillRef idx="3">
-            <a:schemeClr val="accent1"/>
-          </a:fillRef>
-          <a:effectRef idx="2">
-            <a:schemeClr val="accent1"/>
-          </a:effectRef>
-          <a:fontRef idx="minor">
-            <a:schemeClr val="lt1"/>
-          </a:fontRef>
-        </p:style>
-        <p:txBody>
-          <a:bodyPr rtlCol="0" anchor="ctr" lIns="0" rIns="0" tIns="0" bIns="0"/>
-          <a:lstStyle/>
-          <a:p>
-            <a:pPr algn="ctr"/>
-            <a:r>
-              <a:rPr sz="2080" b="1">
-                <a:solidFill>
-                  <a:srgbClr val="FFFFFF"/>
-                </a:solidFill>
-                <a:latin typeface="Arial"/>
-              </a:rPr>
-              <a:t>UBL</a:t>
-            </a:r>
-          </a:p>
-        </p:txBody>
-      </p:sp>
+      <p:pic>
+        <p:nvPicPr>
+          <p:cNvPr id="21" name="Picture 20" descr="ubl-logo.png"/>
+          <p:cNvPicPr>
+            <a:picLocks noChangeAspect="1"/>
+          </p:cNvPicPr>
+          <p:nvPr/>
+        </p:nvPicPr>
+        <p:blipFill>
+          <a:blip r:embed="rId2"/>
+          <a:stretch>
+            <a:fillRect/>
+          </a:stretch>
+        </p:blipFill>
+        <p:spPr>
+          <a:xfrm>
+            <a:off x="822960" y="603504"/>
+            <a:ext cx="1106424" cy="676656"/>
+          </a:xfrm>
+          <a:prstGeom prst="rect">
+            <a:avLst/>
+          </a:prstGeom>
+        </p:spPr>
+      </p:pic>
       <p:sp>
         <p:nvSpPr>
           <p:cNvPr id="22" name="TextBox 21"/>
@@ -4050,7 +4021,7 @@
             <a:r>
               <a:rPr sz="1900" b="0" i="0">
                 <a:solidFill>
-                  <a:srgbClr val="0083CA"/>
+                  <a:srgbClr val="0070B8"/>
                 </a:solidFill>
                 <a:latin typeface="Calibri"/>
               </a:rPr>
@@ -4175,7 +4146,7 @@
             <a:r>
               <a:rPr sz="950" b="1" i="0">
                 <a:solidFill>
-                  <a:srgbClr val="0083CA"/>
+                  <a:srgbClr val="0070B8"/>
                 </a:solidFill>
                 <a:latin typeface="Calibri"/>
               </a:rPr>
@@ -4290,7 +4261,7 @@
             <a:r>
               <a:rPr sz="950" b="1" i="0">
                 <a:solidFill>
-                  <a:srgbClr val="0083CA"/>
+                  <a:srgbClr val="0070B8"/>
                 </a:solidFill>
                 <a:latin typeface="Calibri"/>
               </a:rPr>
@@ -4405,7 +4376,7 @@
             <a:r>
               <a:rPr sz="950" b="1" i="0">
                 <a:solidFill>
-                  <a:srgbClr val="0083CA"/>
+                  <a:srgbClr val="0070B8"/>
                 </a:solidFill>
                 <a:latin typeface="Calibri"/>
               </a:rPr>
@@ -4616,7 +4587,7 @@
             <a:r>
               <a:rPr sz="1050" b="1" i="0">
                 <a:solidFill>
-                  <a:srgbClr val="0083CA"/>
+                  <a:srgbClr val="0070B8"/>
                 </a:solidFill>
                 <a:latin typeface="Calibri"/>
               </a:rPr>
@@ -4780,7 +4751,7 @@
             <a:r>
               <a:rPr sz="950" b="1" i="0">
                 <a:solidFill>
-                  <a:srgbClr val="0083CA"/>
+                  <a:srgbClr val="0070B8"/>
                 </a:solidFill>
                 <a:latin typeface="Calibri"/>
               </a:rPr>
@@ -5273,7 +5244,7 @@
             <a:r>
               <a:rPr sz="1050" b="1" i="0">
                 <a:solidFill>
-                  <a:srgbClr val="0083CA"/>
+                  <a:srgbClr val="0070B8"/>
                 </a:solidFill>
                 <a:latin typeface="Calibri"/>
               </a:rPr>
@@ -5393,7 +5364,7 @@
             <a:r>
               <a:rPr sz="1300" b="1" i="0">
                 <a:solidFill>
-                  <a:srgbClr val="0083CA"/>
+                  <a:srgbClr val="0070B8"/>
                 </a:solidFill>
                 <a:latin typeface="Calibri"/>
               </a:rPr>
@@ -5417,7 +5388,7 @@
             <a:avLst/>
           </a:prstGeom>
           <a:solidFill>
-            <a:srgbClr val="0083CA"/>
+            <a:srgbClr val="0070B8"/>
           </a:solidFill>
           <a:ln>
             <a:noFill/>
@@ -5508,7 +5479,7 @@
             <a:r>
               <a:rPr sz="1000" b="0" i="0">
                 <a:solidFill>
-                  <a:srgbClr val="2199E8"/>
+                  <a:srgbClr val="50A0D0"/>
                 </a:solidFill>
                 <a:latin typeface="Calibri"/>
               </a:rPr>
@@ -5547,7 +5518,7 @@
             <a:r>
               <a:rPr sz="1300" b="1" i="0">
                 <a:solidFill>
-                  <a:srgbClr val="0083CA"/>
+                  <a:srgbClr val="0070B8"/>
                 </a:solidFill>
                 <a:latin typeface="Calibri"/>
               </a:rPr>
@@ -5662,7 +5633,7 @@
             <a:r>
               <a:rPr sz="1000" b="0" i="0">
                 <a:solidFill>
-                  <a:srgbClr val="2199E8"/>
+                  <a:srgbClr val="50A0D0"/>
                 </a:solidFill>
                 <a:latin typeface="Calibri"/>
               </a:rPr>
@@ -5701,7 +5672,7 @@
             <a:r>
               <a:rPr sz="1300" b="1" i="0">
                 <a:solidFill>
-                  <a:srgbClr val="0083CA"/>
+                  <a:srgbClr val="0070B8"/>
                 </a:solidFill>
                 <a:latin typeface="Calibri"/>
               </a:rPr>
@@ -5816,7 +5787,7 @@
             <a:r>
               <a:rPr sz="1000" b="0" i="0">
                 <a:solidFill>
-                  <a:srgbClr val="2199E8"/>
+                  <a:srgbClr val="50A0D0"/>
                 </a:solidFill>
                 <a:latin typeface="Calibri"/>
               </a:rPr>
@@ -5855,7 +5826,7 @@
             <a:r>
               <a:rPr sz="1300" b="1" i="0">
                 <a:solidFill>
-                  <a:srgbClr val="0083CA"/>
+                  <a:srgbClr val="0070B8"/>
                 </a:solidFill>
                 <a:latin typeface="Calibri"/>
               </a:rPr>
@@ -5970,7 +5941,7 @@
             <a:r>
               <a:rPr sz="1000" b="0" i="0">
                 <a:solidFill>
-                  <a:srgbClr val="2199E8"/>
+                  <a:srgbClr val="50A0D0"/>
                 </a:solidFill>
                 <a:latin typeface="Calibri"/>
               </a:rPr>
@@ -6248,7 +6219,7 @@
             <a:r>
               <a:rPr sz="1050" b="1" i="0">
                 <a:solidFill>
-                  <a:srgbClr val="0083CA"/>
+                  <a:srgbClr val="0070B8"/>
                 </a:solidFill>
                 <a:latin typeface="Calibri"/>
               </a:rPr>
@@ -6412,7 +6383,7 @@
             <a:r>
               <a:rPr sz="950" b="1" i="0">
                 <a:solidFill>
-                  <a:srgbClr val="0083CA"/>
+                  <a:srgbClr val="0070B8"/>
                 </a:solidFill>
                 <a:latin typeface="Calibri"/>
               </a:rPr>
@@ -7013,7 +6984,7 @@
             <a:r>
               <a:rPr sz="1050" b="1" i="0">
                 <a:solidFill>
-                  <a:srgbClr val="0083CA"/>
+                  <a:srgbClr val="0070B8"/>
                 </a:solidFill>
                 <a:latin typeface="Calibri"/>
               </a:rPr>
@@ -7507,7 +7478,7 @@
             <a:r>
               <a:rPr sz="950" b="1" i="0">
                 <a:solidFill>
-                  <a:srgbClr val="0083CA"/>
+                  <a:srgbClr val="0070B8"/>
                 </a:solidFill>
                 <a:latin typeface="Calibri"/>
               </a:rPr>
@@ -7562,7 +7533,7 @@
             <a:r>
               <a:rPr sz="950" b="1" i="0">
                 <a:solidFill>
-                  <a:srgbClr val="0083CA"/>
+                  <a:srgbClr val="0070B8"/>
                 </a:solidFill>
                 <a:latin typeface="Calibri"/>
               </a:rPr>

</xml_diff>